<commit_message>
error corrections for uploading to productions
</commit_message>
<xml_diff>
--- a/neerajprojectppt.pptx
+++ b/neerajprojectppt.pptx
@@ -259,7 +259,7 @@
       <p15:sldGuideLst xmlns:p15="http://schemas.microsoft.com/office/powerpoint/2012/main"/>
     </p:ext>
     <p:ext uri="GoogleSlidesCustomDataVersion2">
-      <go:slidesCustomData xmlns:go="http://customooxmlschemas.google.com/" xmlns:ahyp="http://schemas.microsoft.com/office/drawing/2018/hyperlinkcolor" xmlns:p15="http://schemas.microsoft.com/office/powerpoint/2012/main" xmlns:p14="http://schemas.microsoft.com/office/powerpoint/2010/main" xmlns:com="http://schemas.openxmlformats.org/drawingml/2006/compatibility" xmlns:pvml="urn:schemas-microsoft-com:office:powerpoint" xmlns:v="urn:schemas-microsoft-com:vml" xmlns:o="urn:schemas-microsoft-com:office:office" xmlns:dgm="http://schemas.openxmlformats.org/drawingml/2006/diagram" xmlns:c="http://schemas.openxmlformats.org/drawingml/2006/chart" xmlns:mv="urn:schemas-microsoft-com:mac:vml" xmlns:mc="http://schemas.openxmlformats.org/markup-compatibility/2006" xmlns="" r:id="rId27" roundtripDataSignature="AMtx7mjt3491jQ7aCoyIz2WXeHKroE7tpQ=="/>
+      <go:slidesCustomData xmlns="" xmlns:mc="http://schemas.openxmlformats.org/markup-compatibility/2006" xmlns:mv="urn:schemas-microsoft-com:mac:vml" xmlns:c="http://schemas.openxmlformats.org/drawingml/2006/chart" xmlns:dgm="http://schemas.openxmlformats.org/drawingml/2006/diagram" xmlns:o="urn:schemas-microsoft-com:office:office" xmlns:v="urn:schemas-microsoft-com:vml" xmlns:pvml="urn:schemas-microsoft-com:office:powerpoint" xmlns:com="http://schemas.openxmlformats.org/drawingml/2006/compatibility" xmlns:p14="http://schemas.microsoft.com/office/powerpoint/2010/main" xmlns:p15="http://schemas.microsoft.com/office/powerpoint/2012/main" xmlns:ahyp="http://schemas.microsoft.com/office/drawing/2018/hyperlinkcolor" xmlns:go="http://customooxmlschemas.google.com/" r:id="rId27" roundtripDataSignature="AMtx7mjt3491jQ7aCoyIz2WXeHKroE7tpQ=="/>
     </p:ext>
   </p:extLst>
 </p:presentation>
@@ -828,7 +828,7 @@
         <p:cNvPr id="1" name="Shape 197">
           <a:extLst>
             <a:ext uri="{FF2B5EF4-FFF2-40B4-BE49-F238E27FC236}">
-              <a16:creationId xmlns:a16="http://schemas.microsoft.com/office/drawing/2014/main" xmlns="" id="{C2F88CF5-D0C3-0228-6C1A-E849738B9B34}"/>
+              <a16:creationId xmlns="" xmlns:a16="http://schemas.microsoft.com/office/drawing/2014/main" id="{C2F88CF5-D0C3-0228-6C1A-E849738B9B34}"/>
             </a:ext>
           </a:extLst>
         </p:cNvPr>
@@ -848,7 +848,7 @@
           <p:cNvPr id="198" name="Google Shape;198;p10:notes">
             <a:extLst>
               <a:ext uri="{FF2B5EF4-FFF2-40B4-BE49-F238E27FC236}">
-                <a16:creationId xmlns:a16="http://schemas.microsoft.com/office/drawing/2014/main" xmlns="" id="{15C41DBA-EB5E-9EB1-28D2-68EF3081A29D}"/>
+                <a16:creationId xmlns="" xmlns:a16="http://schemas.microsoft.com/office/drawing/2014/main" id="{15C41DBA-EB5E-9EB1-28D2-68EF3081A29D}"/>
               </a:ext>
             </a:extLst>
           </p:cNvPr>
@@ -892,7 +892,7 @@
           <p:cNvPr id="199" name="Google Shape;199;p10:notes">
             <a:extLst>
               <a:ext uri="{FF2B5EF4-FFF2-40B4-BE49-F238E27FC236}">
-                <a16:creationId xmlns:a16="http://schemas.microsoft.com/office/drawing/2014/main" xmlns="" id="{9AACA92E-BC74-25E5-B8D5-2E658F81C2F0}"/>
+                <a16:creationId xmlns="" xmlns:a16="http://schemas.microsoft.com/office/drawing/2014/main" id="{9AACA92E-BC74-25E5-B8D5-2E658F81C2F0}"/>
               </a:ext>
             </a:extLst>
           </p:cNvPr>
@@ -955,7 +955,7 @@
         <p:cNvPr id="1" name="Shape 271">
           <a:extLst>
             <a:ext uri="{FF2B5EF4-FFF2-40B4-BE49-F238E27FC236}">
-              <a16:creationId xmlns:a16="http://schemas.microsoft.com/office/drawing/2014/main" xmlns="" id="{FB18EFA4-CD13-16C4-504B-6DB7E86CE039}"/>
+              <a16:creationId xmlns="" xmlns:a16="http://schemas.microsoft.com/office/drawing/2014/main" id="{FB18EFA4-CD13-16C4-504B-6DB7E86CE039}"/>
             </a:ext>
           </a:extLst>
         </p:cNvPr>
@@ -975,7 +975,7 @@
           <p:cNvPr id="272" name="Google Shape;272;p18:notes">
             <a:extLst>
               <a:ext uri="{FF2B5EF4-FFF2-40B4-BE49-F238E27FC236}">
-                <a16:creationId xmlns:a16="http://schemas.microsoft.com/office/drawing/2014/main" xmlns="" id="{E8E16183-6BFA-E60A-1235-F3BFB1B1F6E4}"/>
+                <a16:creationId xmlns="" xmlns:a16="http://schemas.microsoft.com/office/drawing/2014/main" id="{E8E16183-6BFA-E60A-1235-F3BFB1B1F6E4}"/>
               </a:ext>
             </a:extLst>
           </p:cNvPr>
@@ -1019,7 +1019,7 @@
           <p:cNvPr id="273" name="Google Shape;273;p18:notes">
             <a:extLst>
               <a:ext uri="{FF2B5EF4-FFF2-40B4-BE49-F238E27FC236}">
-                <a16:creationId xmlns:a16="http://schemas.microsoft.com/office/drawing/2014/main" xmlns="" id="{C4420B06-3455-3F20-5E28-90535F24DA27}"/>
+                <a16:creationId xmlns="" xmlns:a16="http://schemas.microsoft.com/office/drawing/2014/main" id="{C4420B06-3455-3F20-5E28-90535F24DA27}"/>
               </a:ext>
             </a:extLst>
           </p:cNvPr>
@@ -1082,7 +1082,7 @@
         <p:cNvPr id="1" name="Shape 271">
           <a:extLst>
             <a:ext uri="{FF2B5EF4-FFF2-40B4-BE49-F238E27FC236}">
-              <a16:creationId xmlns:a16="http://schemas.microsoft.com/office/drawing/2014/main" xmlns="" id="{466C47D1-19F6-52AF-3914-DD3C99058916}"/>
+              <a16:creationId xmlns="" xmlns:a16="http://schemas.microsoft.com/office/drawing/2014/main" id="{466C47D1-19F6-52AF-3914-DD3C99058916}"/>
             </a:ext>
           </a:extLst>
         </p:cNvPr>
@@ -1102,7 +1102,7 @@
           <p:cNvPr id="272" name="Google Shape;272;p18:notes">
             <a:extLst>
               <a:ext uri="{FF2B5EF4-FFF2-40B4-BE49-F238E27FC236}">
-                <a16:creationId xmlns:a16="http://schemas.microsoft.com/office/drawing/2014/main" xmlns="" id="{ACA1F779-4C2B-4CD1-FBDD-A40F0A322340}"/>
+                <a16:creationId xmlns="" xmlns:a16="http://schemas.microsoft.com/office/drawing/2014/main" id="{ACA1F779-4C2B-4CD1-FBDD-A40F0A322340}"/>
               </a:ext>
             </a:extLst>
           </p:cNvPr>
@@ -1146,7 +1146,7 @@
           <p:cNvPr id="273" name="Google Shape;273;p18:notes">
             <a:extLst>
               <a:ext uri="{FF2B5EF4-FFF2-40B4-BE49-F238E27FC236}">
-                <a16:creationId xmlns:a16="http://schemas.microsoft.com/office/drawing/2014/main" xmlns="" id="{40004D30-6E86-E263-D5DA-7577B1C759BC}"/>
+                <a16:creationId xmlns="" xmlns:a16="http://schemas.microsoft.com/office/drawing/2014/main" id="{40004D30-6E86-E263-D5DA-7577B1C759BC}"/>
               </a:ext>
             </a:extLst>
           </p:cNvPr>
@@ -1318,7 +1318,7 @@
         <p:cNvPr id="1" name="Shape 100">
           <a:extLst>
             <a:ext uri="{FF2B5EF4-FFF2-40B4-BE49-F238E27FC236}">
-              <a16:creationId xmlns:a16="http://schemas.microsoft.com/office/drawing/2014/main" xmlns="" id="{48C2B95B-FB15-C156-6AF1-35B35818164E}"/>
+              <a16:creationId xmlns="" xmlns:a16="http://schemas.microsoft.com/office/drawing/2014/main" id="{48C2B95B-FB15-C156-6AF1-35B35818164E}"/>
             </a:ext>
           </a:extLst>
         </p:cNvPr>
@@ -1338,7 +1338,7 @@
           <p:cNvPr id="101" name="Google Shape;101;p3:notes">
             <a:extLst>
               <a:ext uri="{FF2B5EF4-FFF2-40B4-BE49-F238E27FC236}">
-                <a16:creationId xmlns:a16="http://schemas.microsoft.com/office/drawing/2014/main" xmlns="" id="{770A13E9-BC77-63DA-E106-A3FA8022811A}"/>
+                <a16:creationId xmlns="" xmlns:a16="http://schemas.microsoft.com/office/drawing/2014/main" id="{770A13E9-BC77-63DA-E106-A3FA8022811A}"/>
               </a:ext>
             </a:extLst>
           </p:cNvPr>
@@ -1382,7 +1382,7 @@
           <p:cNvPr id="102" name="Google Shape;102;p3:notes">
             <a:extLst>
               <a:ext uri="{FF2B5EF4-FFF2-40B4-BE49-F238E27FC236}">
-                <a16:creationId xmlns:a16="http://schemas.microsoft.com/office/drawing/2014/main" xmlns="" id="{29067B0F-2F4F-7081-A661-0AE31BFBB786}"/>
+                <a16:creationId xmlns="" xmlns:a16="http://schemas.microsoft.com/office/drawing/2014/main" id="{29067B0F-2F4F-7081-A661-0AE31BFBB786}"/>
               </a:ext>
             </a:extLst>
           </p:cNvPr>
@@ -1445,7 +1445,7 @@
         <p:cNvPr id="1" name="Shape 100">
           <a:extLst>
             <a:ext uri="{FF2B5EF4-FFF2-40B4-BE49-F238E27FC236}">
-              <a16:creationId xmlns:a16="http://schemas.microsoft.com/office/drawing/2014/main" xmlns="" id="{20A8E369-C804-D8D2-383B-03E8A5478F53}"/>
+              <a16:creationId xmlns="" xmlns:a16="http://schemas.microsoft.com/office/drawing/2014/main" id="{20A8E369-C804-D8D2-383B-03E8A5478F53}"/>
             </a:ext>
           </a:extLst>
         </p:cNvPr>
@@ -1465,7 +1465,7 @@
           <p:cNvPr id="101" name="Google Shape;101;p3:notes">
             <a:extLst>
               <a:ext uri="{FF2B5EF4-FFF2-40B4-BE49-F238E27FC236}">
-                <a16:creationId xmlns:a16="http://schemas.microsoft.com/office/drawing/2014/main" xmlns="" id="{168FC73D-F867-8E13-0025-1B40818921DD}"/>
+                <a16:creationId xmlns="" xmlns:a16="http://schemas.microsoft.com/office/drawing/2014/main" id="{168FC73D-F867-8E13-0025-1B40818921DD}"/>
               </a:ext>
             </a:extLst>
           </p:cNvPr>
@@ -1509,7 +1509,7 @@
           <p:cNvPr id="102" name="Google Shape;102;p3:notes">
             <a:extLst>
               <a:ext uri="{FF2B5EF4-FFF2-40B4-BE49-F238E27FC236}">
-                <a16:creationId xmlns:a16="http://schemas.microsoft.com/office/drawing/2014/main" xmlns="" id="{449581B4-9B47-7782-B749-078618A6E571}"/>
+                <a16:creationId xmlns="" xmlns:a16="http://schemas.microsoft.com/office/drawing/2014/main" id="{449581B4-9B47-7782-B749-078618A6E571}"/>
               </a:ext>
             </a:extLst>
           </p:cNvPr>
@@ -1572,7 +1572,7 @@
         <p:cNvPr id="1" name="Shape 100">
           <a:extLst>
             <a:ext uri="{FF2B5EF4-FFF2-40B4-BE49-F238E27FC236}">
-              <a16:creationId xmlns:a16="http://schemas.microsoft.com/office/drawing/2014/main" xmlns="" id="{E37D20EF-0791-5303-F96E-0F0C1B50B73D}"/>
+              <a16:creationId xmlns="" xmlns:a16="http://schemas.microsoft.com/office/drawing/2014/main" id="{E37D20EF-0791-5303-F96E-0F0C1B50B73D}"/>
             </a:ext>
           </a:extLst>
         </p:cNvPr>
@@ -1592,7 +1592,7 @@
           <p:cNvPr id="101" name="Google Shape;101;p3:notes">
             <a:extLst>
               <a:ext uri="{FF2B5EF4-FFF2-40B4-BE49-F238E27FC236}">
-                <a16:creationId xmlns:a16="http://schemas.microsoft.com/office/drawing/2014/main" xmlns="" id="{9DCBA8EB-6D71-7B5E-841C-4BFFBDA5F1BE}"/>
+                <a16:creationId xmlns="" xmlns:a16="http://schemas.microsoft.com/office/drawing/2014/main" id="{9DCBA8EB-6D71-7B5E-841C-4BFFBDA5F1BE}"/>
               </a:ext>
             </a:extLst>
           </p:cNvPr>
@@ -1636,7 +1636,7 @@
           <p:cNvPr id="102" name="Google Shape;102;p3:notes">
             <a:extLst>
               <a:ext uri="{FF2B5EF4-FFF2-40B4-BE49-F238E27FC236}">
-                <a16:creationId xmlns:a16="http://schemas.microsoft.com/office/drawing/2014/main" xmlns="" id="{5C2CD162-5BE5-06C8-E06C-B4A49D4BCFF2}"/>
+                <a16:creationId xmlns="" xmlns:a16="http://schemas.microsoft.com/office/drawing/2014/main" id="{5C2CD162-5BE5-06C8-E06C-B4A49D4BCFF2}"/>
               </a:ext>
             </a:extLst>
           </p:cNvPr>
@@ -1699,7 +1699,7 @@
         <p:cNvPr id="1" name="Shape 128">
           <a:extLst>
             <a:ext uri="{FF2B5EF4-FFF2-40B4-BE49-F238E27FC236}">
-              <a16:creationId xmlns:a16="http://schemas.microsoft.com/office/drawing/2014/main" xmlns="" id="{59B870D7-ED5B-C7CD-FB99-2991954CAA65}"/>
+              <a16:creationId xmlns="" xmlns:a16="http://schemas.microsoft.com/office/drawing/2014/main" id="{59B870D7-ED5B-C7CD-FB99-2991954CAA65}"/>
             </a:ext>
           </a:extLst>
         </p:cNvPr>
@@ -1719,7 +1719,7 @@
           <p:cNvPr id="129" name="Google Shape;129;p5:notes">
             <a:extLst>
               <a:ext uri="{FF2B5EF4-FFF2-40B4-BE49-F238E27FC236}">
-                <a16:creationId xmlns:a16="http://schemas.microsoft.com/office/drawing/2014/main" xmlns="" id="{C8B270BB-F67C-52E3-249C-6FE0C237CA97}"/>
+                <a16:creationId xmlns="" xmlns:a16="http://schemas.microsoft.com/office/drawing/2014/main" id="{C8B270BB-F67C-52E3-249C-6FE0C237CA97}"/>
               </a:ext>
             </a:extLst>
           </p:cNvPr>
@@ -1763,7 +1763,7 @@
           <p:cNvPr id="130" name="Google Shape;130;p5:notes">
             <a:extLst>
               <a:ext uri="{FF2B5EF4-FFF2-40B4-BE49-F238E27FC236}">
-                <a16:creationId xmlns:a16="http://schemas.microsoft.com/office/drawing/2014/main" xmlns="" id="{151B863E-6240-36E9-EB23-2DAA667D2518}"/>
+                <a16:creationId xmlns="" xmlns:a16="http://schemas.microsoft.com/office/drawing/2014/main" id="{151B863E-6240-36E9-EB23-2DAA667D2518}"/>
               </a:ext>
             </a:extLst>
           </p:cNvPr>
@@ -1826,7 +1826,7 @@
         <p:cNvPr id="1" name="Shape 170">
           <a:extLst>
             <a:ext uri="{FF2B5EF4-FFF2-40B4-BE49-F238E27FC236}">
-              <a16:creationId xmlns:a16="http://schemas.microsoft.com/office/drawing/2014/main" xmlns="" id="{279463AA-D7FA-5F7E-C4D0-06BDEDCBB932}"/>
+              <a16:creationId xmlns="" xmlns:a16="http://schemas.microsoft.com/office/drawing/2014/main" id="{279463AA-D7FA-5F7E-C4D0-06BDEDCBB932}"/>
             </a:ext>
           </a:extLst>
         </p:cNvPr>
@@ -1846,7 +1846,7 @@
           <p:cNvPr id="171" name="Google Shape;171;p7:notes">
             <a:extLst>
               <a:ext uri="{FF2B5EF4-FFF2-40B4-BE49-F238E27FC236}">
-                <a16:creationId xmlns:a16="http://schemas.microsoft.com/office/drawing/2014/main" xmlns="" id="{A84E3171-2C5C-8738-5718-5608CE1B13A4}"/>
+                <a16:creationId xmlns="" xmlns:a16="http://schemas.microsoft.com/office/drawing/2014/main" id="{A84E3171-2C5C-8738-5718-5608CE1B13A4}"/>
               </a:ext>
             </a:extLst>
           </p:cNvPr>
@@ -1890,7 +1890,7 @@
           <p:cNvPr id="172" name="Google Shape;172;p7:notes">
             <a:extLst>
               <a:ext uri="{FF2B5EF4-FFF2-40B4-BE49-F238E27FC236}">
-                <a16:creationId xmlns:a16="http://schemas.microsoft.com/office/drawing/2014/main" xmlns="" id="{E16E406D-2512-5EF2-0167-6C8953469546}"/>
+                <a16:creationId xmlns="" xmlns:a16="http://schemas.microsoft.com/office/drawing/2014/main" id="{E16E406D-2512-5EF2-0167-6C8953469546}"/>
               </a:ext>
             </a:extLst>
           </p:cNvPr>
@@ -2171,7 +2171,7 @@
         <p:cNvPr id="1" name="Shape 197">
           <a:extLst>
             <a:ext uri="{FF2B5EF4-FFF2-40B4-BE49-F238E27FC236}">
-              <a16:creationId xmlns:a16="http://schemas.microsoft.com/office/drawing/2014/main" xmlns="" id="{11626E4B-E119-2382-6F8F-518641144E90}"/>
+              <a16:creationId xmlns="" xmlns:a16="http://schemas.microsoft.com/office/drawing/2014/main" id="{11626E4B-E119-2382-6F8F-518641144E90}"/>
             </a:ext>
           </a:extLst>
         </p:cNvPr>
@@ -2191,7 +2191,7 @@
           <p:cNvPr id="198" name="Google Shape;198;p10:notes">
             <a:extLst>
               <a:ext uri="{FF2B5EF4-FFF2-40B4-BE49-F238E27FC236}">
-                <a16:creationId xmlns:a16="http://schemas.microsoft.com/office/drawing/2014/main" xmlns="" id="{01A6FF9F-971F-6CD8-61F5-25638A5985F7}"/>
+                <a16:creationId xmlns="" xmlns:a16="http://schemas.microsoft.com/office/drawing/2014/main" id="{01A6FF9F-971F-6CD8-61F5-25638A5985F7}"/>
               </a:ext>
             </a:extLst>
           </p:cNvPr>
@@ -2235,7 +2235,7 @@
           <p:cNvPr id="199" name="Google Shape;199;p10:notes">
             <a:extLst>
               <a:ext uri="{FF2B5EF4-FFF2-40B4-BE49-F238E27FC236}">
-                <a16:creationId xmlns:a16="http://schemas.microsoft.com/office/drawing/2014/main" xmlns="" id="{C8EB5C80-6A4B-AE05-9BE0-03B5AF5C22AD}"/>
+                <a16:creationId xmlns="" xmlns:a16="http://schemas.microsoft.com/office/drawing/2014/main" id="{C8EB5C80-6A4B-AE05-9BE0-03B5AF5C22AD}"/>
               </a:ext>
             </a:extLst>
           </p:cNvPr>
@@ -11808,7 +11808,7 @@
           <p:cNvPr id="2" name="Title 1">
             <a:extLst>
               <a:ext uri="{FF2B5EF4-FFF2-40B4-BE49-F238E27FC236}">
-                <a16:creationId xmlns:a16="http://schemas.microsoft.com/office/drawing/2014/main" xmlns="" id="{9AF97BF8-B3EC-77A2-9BFD-D66830272D56}"/>
+                <a16:creationId xmlns="" xmlns:a16="http://schemas.microsoft.com/office/drawing/2014/main" id="{9AF97BF8-B3EC-77A2-9BFD-D66830272D56}"/>
               </a:ext>
             </a:extLst>
           </p:cNvPr>
@@ -11847,7 +11847,7 @@
           <p:cNvPr id="3" name="Text Placeholder 2">
             <a:extLst>
               <a:ext uri="{FF2B5EF4-FFF2-40B4-BE49-F238E27FC236}">
-                <a16:creationId xmlns:a16="http://schemas.microsoft.com/office/drawing/2014/main" xmlns="" id="{FFAB85A1-2169-FF43-3E91-E2E8ADA742FF}"/>
+                <a16:creationId xmlns="" xmlns:a16="http://schemas.microsoft.com/office/drawing/2014/main" id="{FFAB85A1-2169-FF43-3E91-E2E8ADA742FF}"/>
               </a:ext>
             </a:extLst>
           </p:cNvPr>
@@ -11906,7 +11906,7 @@
         <p:cNvPr id="1" name="Shape 200">
           <a:extLst>
             <a:ext uri="{FF2B5EF4-FFF2-40B4-BE49-F238E27FC236}">
-              <a16:creationId xmlns:a16="http://schemas.microsoft.com/office/drawing/2014/main" xmlns="" id="{7C2A09DE-0AE2-AA94-B2C1-84FDBDB9DC64}"/>
+              <a16:creationId xmlns="" xmlns:a16="http://schemas.microsoft.com/office/drawing/2014/main" id="{7C2A09DE-0AE2-AA94-B2C1-84FDBDB9DC64}"/>
             </a:ext>
           </a:extLst>
         </p:cNvPr>
@@ -11926,7 +11926,7 @@
           <p:cNvPr id="2" name="TextBox 1">
             <a:extLst>
               <a:ext uri="{FF2B5EF4-FFF2-40B4-BE49-F238E27FC236}">
-                <a16:creationId xmlns:a16="http://schemas.microsoft.com/office/drawing/2014/main" xmlns="" id="{151FBD4A-3273-E454-091D-D5B0678FC299}"/>
+                <a16:creationId xmlns="" xmlns:a16="http://schemas.microsoft.com/office/drawing/2014/main" id="{151FBD4A-3273-E454-091D-D5B0678FC299}"/>
               </a:ext>
             </a:extLst>
           </p:cNvPr>
@@ -11962,7 +11962,7 @@
           <p:cNvPr id="3" name="TextBox 2">
             <a:extLst>
               <a:ext uri="{FF2B5EF4-FFF2-40B4-BE49-F238E27FC236}">
-                <a16:creationId xmlns:a16="http://schemas.microsoft.com/office/drawing/2014/main" xmlns="" id="{4A7608B5-9906-EFCF-959A-E89FC2E3EE19}"/>
+                <a16:creationId xmlns="" xmlns:a16="http://schemas.microsoft.com/office/drawing/2014/main" id="{4A7608B5-9906-EFCF-959A-E89FC2E3EE19}"/>
               </a:ext>
             </a:extLst>
           </p:cNvPr>
@@ -12102,11 +12102,7 @@
             </a:r>
             <a:r>
               <a:rPr lang="en-US" sz="1800" dirty="0" smtClean="0"/>
-              <a:t>Interview</a:t>
-            </a:r>
-            <a:r>
-              <a:rPr lang="en-US" sz="1800" dirty="0" smtClean="0"/>
-              <a:t> </a:t>
+              <a:t>Interview </a:t>
             </a:r>
             <a:r>
               <a:rPr lang="en-US" sz="1800" dirty="0"/>
@@ -12164,11 +12160,7 @@
             </a:r>
             <a:r>
               <a:rPr lang="en-IN" sz="1800" dirty="0" smtClean="0"/>
-              <a:t>interview</a:t>
-            </a:r>
-            <a:r>
-              <a:rPr lang="en-IN" sz="1800" dirty="0" smtClean="0"/>
-              <a:t> </a:t>
+              <a:t>interview </a:t>
             </a:r>
             <a:r>
               <a:rPr lang="en-IN" sz="1800" dirty="0"/>
@@ -12207,7 +12199,6 @@
               <a:rPr lang="en-US" sz="1800" dirty="0"/>
               <a:t> playground for a production-ready application feel</a:t>
             </a:r>
-            <a:endParaRPr lang="en-US" sz="1800" dirty="0"/>
           </a:p>
           <a:p>
             <a:pPr marL="285750" indent="-285750">
@@ -12252,7 +12243,7 @@
         <p:cNvPr id="1" name="Shape 200">
           <a:extLst>
             <a:ext uri="{FF2B5EF4-FFF2-40B4-BE49-F238E27FC236}">
-              <a16:creationId xmlns:a16="http://schemas.microsoft.com/office/drawing/2014/main" xmlns="" id="{EEDEC80F-FA4E-F3FF-DE90-87B861D0BD13}"/>
+              <a16:creationId xmlns="" xmlns:a16="http://schemas.microsoft.com/office/drawing/2014/main" id="{EEDEC80F-FA4E-F3FF-DE90-87B861D0BD13}"/>
             </a:ext>
           </a:extLst>
         </p:cNvPr>
@@ -12272,7 +12263,7 @@
           <p:cNvPr id="2" name="TextBox 1">
             <a:extLst>
               <a:ext uri="{FF2B5EF4-FFF2-40B4-BE49-F238E27FC236}">
-                <a16:creationId xmlns:a16="http://schemas.microsoft.com/office/drawing/2014/main" xmlns="" id="{6FA184BA-BCF2-3D7B-30D0-0F3CF30C161B}"/>
+                <a16:creationId xmlns="" xmlns:a16="http://schemas.microsoft.com/office/drawing/2014/main" id="{6FA184BA-BCF2-3D7B-30D0-0F3CF30C161B}"/>
               </a:ext>
             </a:extLst>
           </p:cNvPr>
@@ -12308,7 +12299,7 @@
           <p:cNvPr id="3" name="TextBox 2">
             <a:extLst>
               <a:ext uri="{FF2B5EF4-FFF2-40B4-BE49-F238E27FC236}">
-                <a16:creationId xmlns:a16="http://schemas.microsoft.com/office/drawing/2014/main" xmlns="" id="{ED65F54F-855A-0DB6-09A6-3212C5F7405B}"/>
+                <a16:creationId xmlns="" xmlns:a16="http://schemas.microsoft.com/office/drawing/2014/main" id="{ED65F54F-855A-0DB6-09A6-3212C5F7405B}"/>
               </a:ext>
             </a:extLst>
           </p:cNvPr>
@@ -12477,7 +12468,7 @@
         <p:cNvPr id="1" name="Shape 274">
           <a:extLst>
             <a:ext uri="{FF2B5EF4-FFF2-40B4-BE49-F238E27FC236}">
-              <a16:creationId xmlns:a16="http://schemas.microsoft.com/office/drawing/2014/main" xmlns="" id="{55016524-E738-3D8C-3BB2-B0BE7C665318}"/>
+              <a16:creationId xmlns="" xmlns:a16="http://schemas.microsoft.com/office/drawing/2014/main" id="{55016524-E738-3D8C-3BB2-B0BE7C665318}"/>
             </a:ext>
           </a:extLst>
         </p:cNvPr>
@@ -12497,7 +12488,7 @@
           <p:cNvPr id="278" name="Google Shape;278;p18">
             <a:extLst>
               <a:ext uri="{FF2B5EF4-FFF2-40B4-BE49-F238E27FC236}">
-                <a16:creationId xmlns:a16="http://schemas.microsoft.com/office/drawing/2014/main" xmlns="" id="{D62F03A8-A8A8-CB93-006E-7173DC866F6F}"/>
+                <a16:creationId xmlns="" xmlns:a16="http://schemas.microsoft.com/office/drawing/2014/main" id="{D62F03A8-A8A8-CB93-006E-7173DC866F6F}"/>
               </a:ext>
             </a:extLst>
           </p:cNvPr>
@@ -12557,7 +12548,7 @@
           <p:cNvPr id="279" name="Google Shape;279;p18">
             <a:extLst>
               <a:ext uri="{FF2B5EF4-FFF2-40B4-BE49-F238E27FC236}">
-                <a16:creationId xmlns:a16="http://schemas.microsoft.com/office/drawing/2014/main" xmlns="" id="{15507A2F-9304-7475-5C74-2BAA93879CFE}"/>
+                <a16:creationId xmlns="" xmlns:a16="http://schemas.microsoft.com/office/drawing/2014/main" id="{15507A2F-9304-7475-5C74-2BAA93879CFE}"/>
               </a:ext>
             </a:extLst>
           </p:cNvPr>
@@ -12646,7 +12637,7 @@
           <p:cNvPr id="280" name="Google Shape;280;p18">
             <a:extLst>
               <a:ext uri="{FF2B5EF4-FFF2-40B4-BE49-F238E27FC236}">
-                <a16:creationId xmlns:a16="http://schemas.microsoft.com/office/drawing/2014/main" xmlns="" id="{A4423EF4-BB52-2693-03DD-9F7D92D05218}"/>
+                <a16:creationId xmlns="" xmlns:a16="http://schemas.microsoft.com/office/drawing/2014/main" id="{A4423EF4-BB52-2693-03DD-9F7D92D05218}"/>
               </a:ext>
             </a:extLst>
           </p:cNvPr>
@@ -12718,7 +12709,7 @@
           <p:cNvPr id="281" name="Google Shape;281;p18">
             <a:extLst>
               <a:ext uri="{FF2B5EF4-FFF2-40B4-BE49-F238E27FC236}">
-                <a16:creationId xmlns:a16="http://schemas.microsoft.com/office/drawing/2014/main" xmlns="" id="{FF042814-8077-DBD5-E8B6-E0D870CADB86}"/>
+                <a16:creationId xmlns="" xmlns:a16="http://schemas.microsoft.com/office/drawing/2014/main" id="{FF042814-8077-DBD5-E8B6-E0D870CADB86}"/>
               </a:ext>
             </a:extLst>
           </p:cNvPr>
@@ -12790,7 +12781,7 @@
           <p:cNvPr id="282" name="Google Shape;282;p18">
             <a:extLst>
               <a:ext uri="{FF2B5EF4-FFF2-40B4-BE49-F238E27FC236}">
-                <a16:creationId xmlns:a16="http://schemas.microsoft.com/office/drawing/2014/main" xmlns="" id="{6A2761AF-8A54-98F2-52C2-794D9BA61C92}"/>
+                <a16:creationId xmlns="" xmlns:a16="http://schemas.microsoft.com/office/drawing/2014/main" id="{6A2761AF-8A54-98F2-52C2-794D9BA61C92}"/>
               </a:ext>
             </a:extLst>
           </p:cNvPr>
@@ -12878,7 +12869,7 @@
         <p:cNvPr id="1" name="Shape 274">
           <a:extLst>
             <a:ext uri="{FF2B5EF4-FFF2-40B4-BE49-F238E27FC236}">
-              <a16:creationId xmlns:a16="http://schemas.microsoft.com/office/drawing/2014/main" xmlns="" id="{6FA0F82B-7EE5-EAB0-F470-130BDAC8254B}"/>
+              <a16:creationId xmlns="" xmlns:a16="http://schemas.microsoft.com/office/drawing/2014/main" id="{6FA0F82B-7EE5-EAB0-F470-130BDAC8254B}"/>
             </a:ext>
           </a:extLst>
         </p:cNvPr>
@@ -12898,7 +12889,7 @@
           <p:cNvPr id="278" name="Google Shape;278;p18">
             <a:extLst>
               <a:ext uri="{FF2B5EF4-FFF2-40B4-BE49-F238E27FC236}">
-                <a16:creationId xmlns:a16="http://schemas.microsoft.com/office/drawing/2014/main" xmlns="" id="{0668C6FD-577A-7288-5642-1AFC22BD04F2}"/>
+                <a16:creationId xmlns="" xmlns:a16="http://schemas.microsoft.com/office/drawing/2014/main" id="{0668C6FD-577A-7288-5642-1AFC22BD04F2}"/>
               </a:ext>
             </a:extLst>
           </p:cNvPr>
@@ -12958,7 +12949,7 @@
           <p:cNvPr id="279" name="Google Shape;279;p18">
             <a:extLst>
               <a:ext uri="{FF2B5EF4-FFF2-40B4-BE49-F238E27FC236}">
-                <a16:creationId xmlns:a16="http://schemas.microsoft.com/office/drawing/2014/main" xmlns="" id="{EAFA16CB-0A72-5AC5-69A0-ABF4A752B43F}"/>
+                <a16:creationId xmlns="" xmlns:a16="http://schemas.microsoft.com/office/drawing/2014/main" id="{EAFA16CB-0A72-5AC5-69A0-ABF4A752B43F}"/>
               </a:ext>
             </a:extLst>
           </p:cNvPr>
@@ -13088,7 +13079,7 @@
           <p:cNvPr id="280" name="Google Shape;280;p18">
             <a:extLst>
               <a:ext uri="{FF2B5EF4-FFF2-40B4-BE49-F238E27FC236}">
-                <a16:creationId xmlns:a16="http://schemas.microsoft.com/office/drawing/2014/main" xmlns="" id="{B888011B-E4AC-77DB-4A60-BE2C891C49F5}"/>
+                <a16:creationId xmlns="" xmlns:a16="http://schemas.microsoft.com/office/drawing/2014/main" id="{B888011B-E4AC-77DB-4A60-BE2C891C49F5}"/>
               </a:ext>
             </a:extLst>
           </p:cNvPr>
@@ -13160,7 +13151,7 @@
           <p:cNvPr id="281" name="Google Shape;281;p18">
             <a:extLst>
               <a:ext uri="{FF2B5EF4-FFF2-40B4-BE49-F238E27FC236}">
-                <a16:creationId xmlns:a16="http://schemas.microsoft.com/office/drawing/2014/main" xmlns="" id="{91F05971-9256-10B5-6575-4E7C679C6DAA}"/>
+                <a16:creationId xmlns="" xmlns:a16="http://schemas.microsoft.com/office/drawing/2014/main" id="{91F05971-9256-10B5-6575-4E7C679C6DAA}"/>
               </a:ext>
             </a:extLst>
           </p:cNvPr>
@@ -13232,7 +13223,7 @@
           <p:cNvPr id="282" name="Google Shape;282;p18">
             <a:extLst>
               <a:ext uri="{FF2B5EF4-FFF2-40B4-BE49-F238E27FC236}">
-                <a16:creationId xmlns:a16="http://schemas.microsoft.com/office/drawing/2014/main" xmlns="" id="{F1C3EBC2-438F-C150-9ABF-F14321C2CC5C}"/>
+                <a16:creationId xmlns="" xmlns:a16="http://schemas.microsoft.com/office/drawing/2014/main" id="{F1C3EBC2-438F-C150-9ABF-F14321C2CC5C}"/>
               </a:ext>
             </a:extLst>
           </p:cNvPr>
@@ -13516,28 +13507,28 @@
                 <a:gridCol w="2064867">
                   <a:extLst>
                     <a:ext uri="{9D8B030D-6E8A-4147-A177-3AD203B41FA5}">
-                      <a16:colId xmlns:a16="http://schemas.microsoft.com/office/drawing/2014/main" xmlns="" val="20000"/>
+                      <a16:colId xmlns="" xmlns:a16="http://schemas.microsoft.com/office/drawing/2014/main" val="20000"/>
                     </a:ext>
                   </a:extLst>
                 </a:gridCol>
                 <a:gridCol w="2443374">
                   <a:extLst>
                     <a:ext uri="{9D8B030D-6E8A-4147-A177-3AD203B41FA5}">
-                      <a16:colId xmlns:a16="http://schemas.microsoft.com/office/drawing/2014/main" xmlns="" val="20002"/>
+                      <a16:colId xmlns="" xmlns:a16="http://schemas.microsoft.com/office/drawing/2014/main" val="20002"/>
                     </a:ext>
                   </a:extLst>
                 </a:gridCol>
                 <a:gridCol w="2443374">
                   <a:extLst>
                     <a:ext uri="{9D8B030D-6E8A-4147-A177-3AD203B41FA5}">
-                      <a16:colId xmlns:a16="http://schemas.microsoft.com/office/drawing/2014/main" xmlns="" val="20003"/>
+                      <a16:colId xmlns="" xmlns:a16="http://schemas.microsoft.com/office/drawing/2014/main" val="20003"/>
                     </a:ext>
                   </a:extLst>
                 </a:gridCol>
                 <a:gridCol w="2443374">
                   <a:extLst>
                     <a:ext uri="{9D8B030D-6E8A-4147-A177-3AD203B41FA5}">
-                      <a16:colId xmlns:a16="http://schemas.microsoft.com/office/drawing/2014/main" xmlns="" val="20004"/>
+                      <a16:colId xmlns="" xmlns:a16="http://schemas.microsoft.com/office/drawing/2014/main" val="20004"/>
                     </a:ext>
                   </a:extLst>
                 </a:gridCol>
@@ -13882,7 +13873,7 @@
                 </a:tc>
                 <a:extLst>
                   <a:ext uri="{0D108BD9-81ED-4DB2-BD59-A6C34878D82A}">
-                    <a16:rowId xmlns:a16="http://schemas.microsoft.com/office/drawing/2014/main" xmlns="" val="10000"/>
+                    <a16:rowId xmlns="" xmlns:a16="http://schemas.microsoft.com/office/drawing/2014/main" val="10000"/>
                   </a:ext>
                 </a:extLst>
               </a:tr>
@@ -14147,7 +14138,7 @@
                 </a:tc>
                 <a:extLst>
                   <a:ext uri="{0D108BD9-81ED-4DB2-BD59-A6C34878D82A}">
-                    <a16:rowId xmlns:a16="http://schemas.microsoft.com/office/drawing/2014/main" xmlns="" val="10001"/>
+                    <a16:rowId xmlns="" xmlns:a16="http://schemas.microsoft.com/office/drawing/2014/main" val="10001"/>
                   </a:ext>
                 </a:extLst>
               </a:tr>
@@ -14160,7 +14151,7 @@
           <p:cNvPr id="4" name="TextBox 3">
             <a:extLst>
               <a:ext uri="{FF2B5EF4-FFF2-40B4-BE49-F238E27FC236}">
-                <a16:creationId xmlns:a16="http://schemas.microsoft.com/office/drawing/2014/main" xmlns="" id="{A828B9EF-C084-F5D4-CA27-75AF7D995640}"/>
+                <a16:creationId xmlns="" xmlns:a16="http://schemas.microsoft.com/office/drawing/2014/main" id="{A828B9EF-C084-F5D4-CA27-75AF7D995640}"/>
               </a:ext>
             </a:extLst>
           </p:cNvPr>
@@ -14212,7 +14203,7 @@
           <p:cNvPr id="7" name="TextBox 6">
             <a:extLst>
               <a:ext uri="{FF2B5EF4-FFF2-40B4-BE49-F238E27FC236}">
-                <a16:creationId xmlns:a16="http://schemas.microsoft.com/office/drawing/2014/main" xmlns="" id="{3D723CA3-EC2D-165A-F109-3759C4E9C8A4}"/>
+                <a16:creationId xmlns="" xmlns:a16="http://schemas.microsoft.com/office/drawing/2014/main" id="{3D723CA3-EC2D-165A-F109-3759C4E9C8A4}"/>
               </a:ext>
             </a:extLst>
           </p:cNvPr>
@@ -14301,7 +14292,7 @@
         <p:cNvPr id="1" name="Shape 103">
           <a:extLst>
             <a:ext uri="{FF2B5EF4-FFF2-40B4-BE49-F238E27FC236}">
-              <a16:creationId xmlns:a16="http://schemas.microsoft.com/office/drawing/2014/main" xmlns="" id="{F4C0A7C6-2888-EA53-35AB-4072E6B1FDAC}"/>
+              <a16:creationId xmlns="" xmlns:a16="http://schemas.microsoft.com/office/drawing/2014/main" id="{F4C0A7C6-2888-EA53-35AB-4072E6B1FDAC}"/>
             </a:ext>
           </a:extLst>
         </p:cNvPr>
@@ -14321,7 +14312,7 @@
           <p:cNvPr id="2" name="TextBox 1">
             <a:extLst>
               <a:ext uri="{FF2B5EF4-FFF2-40B4-BE49-F238E27FC236}">
-                <a16:creationId xmlns:a16="http://schemas.microsoft.com/office/drawing/2014/main" xmlns="" id="{C6F6745E-14BA-0766-CE1E-32E29663832D}"/>
+                <a16:creationId xmlns="" xmlns:a16="http://schemas.microsoft.com/office/drawing/2014/main" id="{C6F6745E-14BA-0766-CE1E-32E29663832D}"/>
               </a:ext>
             </a:extLst>
           </p:cNvPr>
@@ -14528,7 +14519,7 @@
           <p:cNvPr id="3" name="TextBox 2">
             <a:extLst>
               <a:ext uri="{FF2B5EF4-FFF2-40B4-BE49-F238E27FC236}">
-                <a16:creationId xmlns:a16="http://schemas.microsoft.com/office/drawing/2014/main" xmlns="" id="{3847FA31-EA47-D27A-9D69-AF50A3080AEC}"/>
+                <a16:creationId xmlns="" xmlns:a16="http://schemas.microsoft.com/office/drawing/2014/main" id="{3847FA31-EA47-D27A-9D69-AF50A3080AEC}"/>
               </a:ext>
             </a:extLst>
           </p:cNvPr>
@@ -14587,7 +14578,7 @@
         <p:cNvPr id="1" name="Shape 103">
           <a:extLst>
             <a:ext uri="{FF2B5EF4-FFF2-40B4-BE49-F238E27FC236}">
-              <a16:creationId xmlns:a16="http://schemas.microsoft.com/office/drawing/2014/main" xmlns="" id="{6A77E81F-021A-57FB-C709-7E7075649101}"/>
+              <a16:creationId xmlns="" xmlns:a16="http://schemas.microsoft.com/office/drawing/2014/main" id="{6A77E81F-021A-57FB-C709-7E7075649101}"/>
             </a:ext>
           </a:extLst>
         </p:cNvPr>
@@ -14607,7 +14598,7 @@
           <p:cNvPr id="2" name="TextBox 1">
             <a:extLst>
               <a:ext uri="{FF2B5EF4-FFF2-40B4-BE49-F238E27FC236}">
-                <a16:creationId xmlns:a16="http://schemas.microsoft.com/office/drawing/2014/main" xmlns="" id="{07CFCB91-EF22-EB8C-5B0D-4D46021F0245}"/>
+                <a16:creationId xmlns="" xmlns:a16="http://schemas.microsoft.com/office/drawing/2014/main" id="{07CFCB91-EF22-EB8C-5B0D-4D46021F0245}"/>
               </a:ext>
             </a:extLst>
           </p:cNvPr>
@@ -14711,7 +14702,7 @@
           <p:cNvPr id="3" name="TextBox 2">
             <a:extLst>
               <a:ext uri="{FF2B5EF4-FFF2-40B4-BE49-F238E27FC236}">
-                <a16:creationId xmlns:a16="http://schemas.microsoft.com/office/drawing/2014/main" xmlns="" id="{FBD926A1-0833-2949-651F-2AAB4D91A8C9}"/>
+                <a16:creationId xmlns="" xmlns:a16="http://schemas.microsoft.com/office/drawing/2014/main" id="{FBD926A1-0833-2949-651F-2AAB4D91A8C9}"/>
               </a:ext>
             </a:extLst>
           </p:cNvPr>
@@ -14763,7 +14754,7 @@
         <p:cNvPr id="1" name="Shape 103">
           <a:extLst>
             <a:ext uri="{FF2B5EF4-FFF2-40B4-BE49-F238E27FC236}">
-              <a16:creationId xmlns:a16="http://schemas.microsoft.com/office/drawing/2014/main" xmlns="" id="{0471B467-61AA-7BCA-460D-43041E805F9C}"/>
+              <a16:creationId xmlns="" xmlns:a16="http://schemas.microsoft.com/office/drawing/2014/main" id="{0471B467-61AA-7BCA-460D-43041E805F9C}"/>
             </a:ext>
           </a:extLst>
         </p:cNvPr>
@@ -14783,7 +14774,7 @@
           <p:cNvPr id="2" name="TextBox 1">
             <a:extLst>
               <a:ext uri="{FF2B5EF4-FFF2-40B4-BE49-F238E27FC236}">
-                <a16:creationId xmlns:a16="http://schemas.microsoft.com/office/drawing/2014/main" xmlns="" id="{4A1BF701-ABCA-4DF0-8330-B6AF71EF8E39}"/>
+                <a16:creationId xmlns="" xmlns:a16="http://schemas.microsoft.com/office/drawing/2014/main" id="{4A1BF701-ABCA-4DF0-8330-B6AF71EF8E39}"/>
               </a:ext>
             </a:extLst>
           </p:cNvPr>
@@ -14966,7 +14957,6 @@
               <a:rPr lang="en-US" dirty="0"/>
               <a:t> Professional, minimalistic chat UI built to isolate the user from the backend logic. </a:t>
             </a:r>
-            <a:endParaRPr lang="en-US" dirty="0"/>
           </a:p>
           <a:p>
             <a:endParaRPr lang="en-IN" dirty="0"/>
@@ -14978,7 +14968,7 @@
           <p:cNvPr id="3" name="TextBox 2">
             <a:extLst>
               <a:ext uri="{FF2B5EF4-FFF2-40B4-BE49-F238E27FC236}">
-                <a16:creationId xmlns:a16="http://schemas.microsoft.com/office/drawing/2014/main" xmlns="" id="{527F30CC-07EF-8FCC-DA00-C9212F5DAECE}"/>
+                <a16:creationId xmlns="" xmlns:a16="http://schemas.microsoft.com/office/drawing/2014/main" id="{527F30CC-07EF-8FCC-DA00-C9212F5DAECE}"/>
               </a:ext>
             </a:extLst>
           </p:cNvPr>
@@ -15030,7 +15020,7 @@
         <p:cNvPr id="1" name="Shape 131">
           <a:extLst>
             <a:ext uri="{FF2B5EF4-FFF2-40B4-BE49-F238E27FC236}">
-              <a16:creationId xmlns:a16="http://schemas.microsoft.com/office/drawing/2014/main" xmlns="" id="{CDF2A78E-5A0E-6814-8AF4-0AE54B0366E1}"/>
+              <a16:creationId xmlns="" xmlns:a16="http://schemas.microsoft.com/office/drawing/2014/main" id="{CDF2A78E-5A0E-6814-8AF4-0AE54B0366E1}"/>
             </a:ext>
           </a:extLst>
         </p:cNvPr>
@@ -15050,7 +15040,7 @@
           <p:cNvPr id="135" name="Google Shape;135;p5">
             <a:extLst>
               <a:ext uri="{FF2B5EF4-FFF2-40B4-BE49-F238E27FC236}">
-                <a16:creationId xmlns:a16="http://schemas.microsoft.com/office/drawing/2014/main" xmlns="" id="{2A145802-2DD3-EEBA-7D44-210C05B98C91}"/>
+                <a16:creationId xmlns="" xmlns:a16="http://schemas.microsoft.com/office/drawing/2014/main" id="{2A145802-2DD3-EEBA-7D44-210C05B98C91}"/>
               </a:ext>
             </a:extLst>
           </p:cNvPr>
@@ -15128,7 +15118,7 @@
           <p:cNvPr id="148" name="Google Shape;148;p5">
             <a:extLst>
               <a:ext uri="{FF2B5EF4-FFF2-40B4-BE49-F238E27FC236}">
-                <a16:creationId xmlns:a16="http://schemas.microsoft.com/office/drawing/2014/main" xmlns="" id="{69E3EADC-1EAD-7419-145C-20998925206E}"/>
+                <a16:creationId xmlns="" xmlns:a16="http://schemas.microsoft.com/office/drawing/2014/main" id="{69E3EADC-1EAD-7419-145C-20998925206E}"/>
               </a:ext>
             </a:extLst>
           </p:cNvPr>
@@ -15188,7 +15178,7 @@
           <p:cNvPr id="149" name="Google Shape;149;p5">
             <a:extLst>
               <a:ext uri="{FF2B5EF4-FFF2-40B4-BE49-F238E27FC236}">
-                <a16:creationId xmlns:a16="http://schemas.microsoft.com/office/drawing/2014/main" xmlns="" id="{04E5872A-C331-C8F3-5D71-8E953BAAFE03}"/>
+                <a16:creationId xmlns="" xmlns:a16="http://schemas.microsoft.com/office/drawing/2014/main" id="{04E5872A-C331-C8F3-5D71-8E953BAAFE03}"/>
               </a:ext>
             </a:extLst>
           </p:cNvPr>
@@ -15248,7 +15238,7 @@
           <p:cNvPr id="150" name="Google Shape;150;p5">
             <a:extLst>
               <a:ext uri="{FF2B5EF4-FFF2-40B4-BE49-F238E27FC236}">
-                <a16:creationId xmlns:a16="http://schemas.microsoft.com/office/drawing/2014/main" xmlns="" id="{76EF3801-5D99-5EFA-9AA2-AD265775E354}"/>
+                <a16:creationId xmlns="" xmlns:a16="http://schemas.microsoft.com/office/drawing/2014/main" id="{76EF3801-5D99-5EFA-9AA2-AD265775E354}"/>
               </a:ext>
             </a:extLst>
           </p:cNvPr>
@@ -15308,7 +15298,7 @@
           <p:cNvPr id="151" name="Google Shape;151;p5">
             <a:extLst>
               <a:ext uri="{FF2B5EF4-FFF2-40B4-BE49-F238E27FC236}">
-                <a16:creationId xmlns:a16="http://schemas.microsoft.com/office/drawing/2014/main" xmlns="" id="{DAD76A8A-9F2C-9EA9-25E9-40CD0FFAA869}"/>
+                <a16:creationId xmlns="" xmlns:a16="http://schemas.microsoft.com/office/drawing/2014/main" id="{DAD76A8A-9F2C-9EA9-25E9-40CD0FFAA869}"/>
               </a:ext>
             </a:extLst>
           </p:cNvPr>
@@ -15368,7 +15358,7 @@
           <p:cNvPr id="152" name="Google Shape;152;p5">
             <a:extLst>
               <a:ext uri="{FF2B5EF4-FFF2-40B4-BE49-F238E27FC236}">
-                <a16:creationId xmlns:a16="http://schemas.microsoft.com/office/drawing/2014/main" xmlns="" id="{8D9C4260-2673-337C-C898-4C22E0F8FD65}"/>
+                <a16:creationId xmlns="" xmlns:a16="http://schemas.microsoft.com/office/drawing/2014/main" id="{8D9C4260-2673-337C-C898-4C22E0F8FD65}"/>
               </a:ext>
             </a:extLst>
           </p:cNvPr>
@@ -15428,7 +15418,7 @@
           <p:cNvPr id="153" name="Google Shape;153;p5">
             <a:extLst>
               <a:ext uri="{FF2B5EF4-FFF2-40B4-BE49-F238E27FC236}">
-                <a16:creationId xmlns:a16="http://schemas.microsoft.com/office/drawing/2014/main" xmlns="" id="{6167C3C6-3747-E373-84C3-3927C443B067}"/>
+                <a16:creationId xmlns="" xmlns:a16="http://schemas.microsoft.com/office/drawing/2014/main" id="{6167C3C6-3747-E373-84C3-3927C443B067}"/>
               </a:ext>
             </a:extLst>
           </p:cNvPr>
@@ -15488,7 +15478,7 @@
           <p:cNvPr id="2" name="TextBox 1">
             <a:extLst>
               <a:ext uri="{FF2B5EF4-FFF2-40B4-BE49-F238E27FC236}">
-                <a16:creationId xmlns:a16="http://schemas.microsoft.com/office/drawing/2014/main" xmlns="" id="{9BB86949-7ED1-C43B-B1E3-5122BB67A596}"/>
+                <a16:creationId xmlns="" xmlns:a16="http://schemas.microsoft.com/office/drawing/2014/main" id="{9BB86949-7ED1-C43B-B1E3-5122BB67A596}"/>
               </a:ext>
             </a:extLst>
           </p:cNvPr>
@@ -15644,7 +15634,6 @@
               <a:rPr lang="en-US" dirty="0"/>
               <a:t> Used for retrieving domain-specific interview questions from college datasets.</a:t>
             </a:r>
-            <a:endParaRPr lang="en-US" dirty="0"/>
           </a:p>
           <a:p>
             <a:endParaRPr lang="en-US" dirty="0" smtClean="0"/>
@@ -15690,7 +15679,6 @@
               <a:rPr lang="en-US" dirty="0"/>
               <a:t> of interview questions, enabling semantic search rather than simple keyword matching.</a:t>
             </a:r>
-            <a:endParaRPr lang="en-US" dirty="0"/>
           </a:p>
           <a:p>
             <a:endParaRPr lang="en-US" dirty="0"/>
@@ -15723,6 +15711,13 @@
   <p:clrMapOvr>
     <a:masterClrMapping/>
   </p:clrMapOvr>
+  <p:timing>
+    <p:tnLst>
+      <p:par>
+        <p:cTn id="1" dur="indefinite" restart="never" nodeType="tmRoot"/>
+      </p:par>
+    </p:tnLst>
+  </p:timing>
 </p:sld>
 </file>
 
@@ -15734,7 +15729,7 @@
         <p:cNvPr id="1" name="Shape 173">
           <a:extLst>
             <a:ext uri="{FF2B5EF4-FFF2-40B4-BE49-F238E27FC236}">
-              <a16:creationId xmlns:a16="http://schemas.microsoft.com/office/drawing/2014/main" xmlns="" id="{CA6090C0-0478-84F9-6D20-717B6FEB7326}"/>
+              <a16:creationId xmlns="" xmlns:a16="http://schemas.microsoft.com/office/drawing/2014/main" id="{CA6090C0-0478-84F9-6D20-717B6FEB7326}"/>
             </a:ext>
           </a:extLst>
         </p:cNvPr>
@@ -15754,7 +15749,7 @@
           <p:cNvPr id="2" name="Google Shape;135;p5">
             <a:extLst>
               <a:ext uri="{FF2B5EF4-FFF2-40B4-BE49-F238E27FC236}">
-                <a16:creationId xmlns:a16="http://schemas.microsoft.com/office/drawing/2014/main" xmlns="" id="{B64CF172-D2AF-03D8-F919-AA7827A0D969}"/>
+                <a16:creationId xmlns="" xmlns:a16="http://schemas.microsoft.com/office/drawing/2014/main" id="{B64CF172-D2AF-03D8-F919-AA7827A0D969}"/>
               </a:ext>
             </a:extLst>
           </p:cNvPr>
@@ -15861,6 +15856,13 @@
   <p:clrMapOvr>
     <a:masterClrMapping/>
   </p:clrMapOvr>
+  <p:timing>
+    <p:tnLst>
+      <p:par>
+        <p:cTn id="1" dur="indefinite" restart="never" nodeType="tmRoot"/>
+      </p:par>
+    </p:tnLst>
+  </p:timing>
 </p:sld>
 </file>
 
@@ -15913,7 +15915,7 @@
           <p:cNvPr id="2" name="Google Shape;135;p5">
             <a:extLst>
               <a:ext uri="{FF2B5EF4-FFF2-40B4-BE49-F238E27FC236}">
-                <a16:creationId xmlns:a16="http://schemas.microsoft.com/office/drawing/2014/main" xmlns="" id="{78578745-3233-E2C4-2AF4-55BA57C68D3F}"/>
+                <a16:creationId xmlns="" xmlns:a16="http://schemas.microsoft.com/office/drawing/2014/main" id="{78578745-3233-E2C4-2AF4-55BA57C68D3F}"/>
               </a:ext>
             </a:extLst>
           </p:cNvPr>
@@ -15961,6 +15963,13 @@
   <p:clrMapOvr>
     <a:masterClrMapping/>
   </p:clrMapOvr>
+  <p:timing>
+    <p:tnLst>
+      <p:par>
+        <p:cTn id="1" dur="indefinite" restart="never" nodeType="tmRoot"/>
+      </p:par>
+    </p:tnLst>
+  </p:timing>
 </p:sld>
 </file>
 
@@ -15986,7 +15995,7 @@
           <p:cNvPr id="2" name="TextBox 1">
             <a:extLst>
               <a:ext uri="{FF2B5EF4-FFF2-40B4-BE49-F238E27FC236}">
-                <a16:creationId xmlns:a16="http://schemas.microsoft.com/office/drawing/2014/main" xmlns="" id="{B84A7B44-8B20-5A39-ED43-DA98D0FC7976}"/>
+                <a16:creationId xmlns="" xmlns:a16="http://schemas.microsoft.com/office/drawing/2014/main" id="{B84A7B44-8B20-5A39-ED43-DA98D0FC7976}"/>
               </a:ext>
             </a:extLst>
           </p:cNvPr>
@@ -16022,7 +16031,7 @@
           <p:cNvPr id="3" name="TextBox 2">
             <a:extLst>
               <a:ext uri="{FF2B5EF4-FFF2-40B4-BE49-F238E27FC236}">
-                <a16:creationId xmlns:a16="http://schemas.microsoft.com/office/drawing/2014/main" xmlns="" id="{322462E8-EB3A-DA7D-44CB-4E757803A755}"/>
+                <a16:creationId xmlns="" xmlns:a16="http://schemas.microsoft.com/office/drawing/2014/main" id="{322462E8-EB3A-DA7D-44CB-4E757803A755}"/>
               </a:ext>
             </a:extLst>
           </p:cNvPr>
@@ -16121,7 +16130,6 @@
               <a:rPr lang="en-US" dirty="0"/>
               <a:t> AI makes the system proactive and goal-driven, acting exactly like a strict Senior Developer evaluating a candidate.</a:t>
             </a:r>
-            <a:endParaRPr lang="en-US" dirty="0"/>
           </a:p>
         </p:txBody>
       </p:sp>
@@ -16143,6 +16151,30 @@
           <a:xfrm>
             <a:off x="8028432" y="443610"/>
             <a:ext cx="3749365" cy="5875529"/>
+          </a:xfrm>
+          <a:prstGeom prst="rect">
+            <a:avLst/>
+          </a:prstGeom>
+        </p:spPr>
+      </p:pic>
+      <p:pic>
+        <p:nvPicPr>
+          <p:cNvPr id="4" name="Picture 3"/>
+          <p:cNvPicPr>
+            <a:picLocks noChangeAspect="1"/>
+          </p:cNvPicPr>
+          <p:nvPr/>
+        </p:nvPicPr>
+        <p:blipFill>
+          <a:blip r:embed="rId4"/>
+          <a:stretch>
+            <a:fillRect/>
+          </a:stretch>
+        </p:blipFill>
+        <p:spPr>
+          <a:xfrm>
+            <a:off x="7915275" y="382644"/>
+            <a:ext cx="4094078" cy="5997460"/>
           </a:xfrm>
           <a:prstGeom prst="rect">
             <a:avLst/>

</xml_diff>